<commit_message>
Add advanced analytics stack: SQL modeling, PySpark, QA, logging, cloud docs, and BI exports
</commit_message>
<xml_diff>
--- a/dashboard/Marketing_Data_Pipeline_Presentation.pptx
+++ b/dashboard/Marketing_Data_Pipeline_Presentation.pptx
@@ -17,6 +17,10 @@
     <p:sldId id="265" r:id="rId16"/>
     <p:sldId id="266" r:id="rId17"/>
     <p:sldId id="267" r:id="rId18"/>
+    <p:sldId id="268" r:id="rId19"/>
+    <p:sldId id="269" r:id="rId20"/>
+    <p:sldId id="270" r:id="rId21"/>
+    <p:sldId id="271" r:id="rId22"/>
   </p:sldIdLst>
   <p:sldSz cx="12191695" cy="6858000" type="screen4x3"/>
   <p:notesSz cx="6858000" cy="9144000"/>
@@ -3236,7 +3240,7 @@
               </a:defRPr>
             </a:pPr>
             <a:r>
-              <a:t>Pipeline automation</a:t>
+              <a:t>Dimensional data model (star schema)</a:t>
             </a:r>
           </a:p>
         </p:txBody>
@@ -3272,7 +3276,7 @@
               </a:defRPr>
             </a:pPr>
             <a:r>
-              <a:t>One command executes every stage end-to-end, from data generation to dashboard output.</a:t>
+              <a:t>Introduced schema design with fact_campaign_daily and dimensions for campaign, channel, and date.</a:t>
             </a:r>
           </a:p>
           <a:p>
@@ -3285,7 +3289,7 @@
               </a:defRPr>
             </a:pPr>
             <a:r>
-              <a:t>This makes the workflow repeatable, fast to demo, and simple to maintain.</a:t>
+              <a:t>Model supports scalable BI slicing (time, campaign, channel) and cleaner semantic reporting.</a:t>
             </a:r>
           </a:p>
           <a:p>
@@ -3298,7 +3302,7 @@
               </a:defRPr>
             </a:pPr>
             <a:r>
-              <a:t>Each step is modular (generate, clean, load, analyze, visualize) for easy extension.</a:t>
+              <a:t>Loaded entities: campaigns=5, channels=4, dates=180, fact rows=900</a:t>
             </a:r>
           </a:p>
         </p:txBody>
@@ -3311,8 +3315,8 @@
         </p:nvSpPr>
         <p:spPr>
           <a:xfrm>
-            <a:off x="1828800" y="3657600"/>
-            <a:ext cx="8503920" cy="2103120"/>
+            <a:off x="1097280" y="3657600"/>
+            <a:ext cx="10241280" cy="2011680"/>
           </a:xfrm>
           <a:prstGeom prst="roundRect">
             <a:avLst/>
@@ -3353,20 +3357,19 @@
               </a:defRPr>
             </a:pPr>
             <a:r>
-              <a:t>python3 scripts/run_pipeline.py</a:t>
+              <a:t>fact_campaign_daily(date_key, campaign_key, impressions, clicks, cost, conversions, ctr, cpc, cpa)</a:t>
             </a:r>
             <a:br/>
+            <a:r>
+              <a:t>dim_campaign(campaign_key, campaign_id, channel_key)</a:t>
+            </a:r>
             <a:br/>
             <a:r>
-              <a:t># executes:</a:t>
+              <a:t>dim_channel(channel_key, channel_name)</a:t>
             </a:r>
             <a:br/>
             <a:r>
-              <a:t># generate_data.py -&gt; clean_data.py -&gt; load_data.py</a:t>
-            </a:r>
-            <a:br/>
-            <a:r>
-              <a:t># -&gt; run_analysis.py -&gt; generate_dashboard.py</a:t>
+              <a:t>dim_date(date_key, date_value, year, month, day, week_of_year)</a:t>
             </a:r>
           </a:p>
         </p:txBody>
@@ -3428,7 +3431,7 @@
               </a:defRPr>
             </a:pPr>
             <a:r>
-              <a:t>Key insights from the data</a:t>
+              <a:t>PySpark processing for scale</a:t>
             </a:r>
           </a:p>
         </p:txBody>
@@ -3442,7 +3445,7 @@
         <p:spPr>
           <a:xfrm>
             <a:off x="822960" y="1645920"/>
-            <a:ext cx="10972800" cy="4389120"/>
+            <a:ext cx="6583680" cy="4389120"/>
           </a:xfrm>
           <a:prstGeom prst="rect">
             <a:avLst/>
@@ -3464,7 +3467,7 @@
               </a:defRPr>
             </a:pPr>
             <a:r>
-              <a:t>Search_Google drives the largest spend and strongest CTR, making it a high-volume performance engine.</a:t>
+              <a:t>Raw CSV loaded with explicit schema in Spark DataFrames.</a:t>
             </a:r>
           </a:p>
           <a:p>
@@ -3477,7 +3480,7 @@
               </a:defRPr>
             </a:pPr>
             <a:r>
-              <a:t>Email_Newsletter delivers the most efficient acquisition cost (lowest CPA), indicating high conversion efficiency.</a:t>
+              <a:t>Applied null handling, type cleanup, metric enrichment (CTR/CPC/CPA), and campaign-date aggregation.</a:t>
             </a:r>
           </a:p>
           <a:p>
@@ -3490,7 +3493,7 @@
               </a:defRPr>
             </a:pPr>
             <a:r>
-              <a:t>Display_Programmatic has the weakest CTR and highest CPA, suggesting creative or targeting optimization is needed.</a:t>
+              <a:t>Used Spark window functions for lag clicks and rolling 7-day average CTR.</a:t>
             </a:r>
           </a:p>
           <a:p>
@@ -3503,7 +3506,70 @@
               </a:defRPr>
             </a:pPr>
             <a:r>
-              <a:t>Cross-channel visibility helps rebalance budget toward both scale (Search) and efficiency (Email).</a:t>
+              <a:t>Wrote curated parquet output for cloud-ready downstream processing.</a:t>
+            </a:r>
+          </a:p>
+        </p:txBody>
+      </p:sp>
+      <p:sp>
+        <p:nvSpPr>
+          <p:cNvPr id="4" name="Rounded Rectangle 3"/>
+          <p:cNvSpPr/>
+          <p:nvPr/>
+        </p:nvSpPr>
+        <p:spPr>
+          <a:xfrm>
+            <a:off x="7040880" y="1828800"/>
+            <a:ext cx="4480560" cy="2103120"/>
+          </a:xfrm>
+          <a:prstGeom prst="roundRect">
+            <a:avLst/>
+          </a:prstGeom>
+          <a:solidFill>
+            <a:srgbClr val="1A2334"/>
+          </a:solidFill>
+          <a:ln>
+            <a:solidFill>
+              <a:srgbClr val="0086AD"/>
+            </a:solidFill>
+          </a:ln>
+        </p:spPr>
+        <p:style>
+          <a:lnRef idx="1">
+            <a:schemeClr val="accent1"/>
+          </a:lnRef>
+          <a:fillRef idx="3">
+            <a:schemeClr val="accent1"/>
+          </a:fillRef>
+          <a:effectRef idx="2">
+            <a:schemeClr val="accent1"/>
+          </a:effectRef>
+          <a:fontRef idx="minor">
+            <a:schemeClr val="lt1"/>
+          </a:fontRef>
+        </p:style>
+        <p:txBody>
+          <a:bodyPr rtlCol="0" anchor="ctr"/>
+          <a:lstStyle/>
+          <a:p>
+            <a:pPr algn="ctr">
+              <a:defRPr sz="1200">
+                <a:solidFill>
+                  <a:srgbClr val="FFFFFF"/>
+                </a:solidFill>
+                <a:latin typeface="Consolas"/>
+              </a:defRPr>
+            </a:pPr>
+            <a:r>
+              <a:t>w = Window.partitionBy('campaign_id').orderBy('date')</a:t>
+            </a:r>
+            <a:br/>
+            <a:r>
+              <a:t>df = df.withColumn('prev_day_clicks', F.lag('clicks', 1).over(w))</a:t>
+            </a:r>
+            <a:br/>
+            <a:r>
+              <a:t>df = df.withColumn('rolling_7d_avg_ctr', F.avg('ctr').over(w.rowsBetween(-6, 0)))</a:t>
             </a:r>
           </a:p>
         </p:txBody>
@@ -3517,6 +3583,592 @@
 </file>
 
 <file path=ppt/slides/slide12.xml><?xml version="1.0" encoding="utf-8"?>
+<p:sld xmlns:a="http://schemas.openxmlformats.org/drawingml/2006/main" xmlns:p="http://schemas.openxmlformats.org/presentationml/2006/main" xmlns:r="http://schemas.openxmlformats.org/officeDocument/2006/relationships">
+  <p:cSld>
+    <p:bg>
+      <p:bgPr>
+        <a:solidFill>
+          <a:srgbClr val="F5F8FC"/>
+        </a:solidFill>
+        <a:effectLst/>
+      </p:bgPr>
+    </p:bg>
+    <p:spTree>
+      <p:nvGrpSpPr>
+        <p:cNvPr id="1" name=""/>
+        <p:cNvGrpSpPr/>
+        <p:nvPr/>
+      </p:nvGrpSpPr>
+      <p:grpSpPr/>
+      <p:sp>
+        <p:nvSpPr>
+          <p:cNvPr id="2" name="TextBox 1"/>
+          <p:cNvSpPr txBox="1"/>
+          <p:nvPr/>
+        </p:nvSpPr>
+        <p:spPr>
+          <a:xfrm>
+            <a:off x="640080" y="320040"/>
+            <a:ext cx="10972800" cy="822960"/>
+          </a:xfrm>
+          <a:prstGeom prst="rect">
+            <a:avLst/>
+          </a:prstGeom>
+          <a:noFill/>
+        </p:spPr>
+        <p:txBody>
+          <a:bodyPr wrap="none">
+            <a:spAutoFit/>
+          </a:bodyPr>
+          <a:lstStyle/>
+          <a:p>
+            <a:pPr>
+              <a:defRPr sz="3600" b="1">
+                <a:solidFill>
+                  <a:srgbClr val="0D1B3E"/>
+                </a:solidFill>
+                <a:latin typeface="Calibri"/>
+              </a:defRPr>
+            </a:pPr>
+            <a:r>
+              <a:t>Data quality and testing framework</a:t>
+            </a:r>
+          </a:p>
+        </p:txBody>
+      </p:sp>
+      <p:sp>
+        <p:nvSpPr>
+          <p:cNvPr id="3" name="TextBox 2"/>
+          <p:cNvSpPr txBox="1"/>
+          <p:nvPr/>
+        </p:nvSpPr>
+        <p:spPr>
+          <a:xfrm>
+            <a:off x="822960" y="1645920"/>
+            <a:ext cx="10972800" cy="4389120"/>
+          </a:xfrm>
+          <a:prstGeom prst="rect">
+            <a:avLst/>
+          </a:prstGeom>
+          <a:noFill/>
+        </p:spPr>
+        <p:txBody>
+          <a:bodyPr wrap="none">
+            <a:spAutoFit/>
+          </a:bodyPr>
+          <a:lstStyle/>
+          <a:p>
+            <a:pPr>
+              <a:defRPr sz="1800">
+                <a:solidFill>
+                  <a:srgbClr val="242E42"/>
+                </a:solidFill>
+                <a:latin typeface="Calibri"/>
+              </a:defRPr>
+            </a:pPr>
+            <a:r>
+              <a:t>Automated quality checks after cleaning: nulls, ranges, duplicates, completeness, and row-count validation.</a:t>
+            </a:r>
+          </a:p>
+          <a:p>
+            <a:pPr>
+              <a:defRPr sz="1800">
+                <a:solidFill>
+                  <a:srgbClr val="242E42"/>
+                </a:solidFill>
+                <a:latin typeface="Calibri"/>
+              </a:defRPr>
+            </a:pPr>
+            <a:r>
+              <a:t>Checks are logged with PASS/FAIL outcomes to quality_report.txt for auditability.</a:t>
+            </a:r>
+          </a:p>
+          <a:p>
+            <a:pPr>
+              <a:defRPr sz="1800">
+                <a:solidFill>
+                  <a:srgbClr val="242E42"/>
+                </a:solidFill>
+                <a:latin typeface="Calibri"/>
+              </a:defRPr>
+            </a:pPr>
+            <a:r>
+              <a:t>Pytest suite validates cleaning logic, loading behavior, SQL structures, model creation, and exports.</a:t>
+            </a:r>
+          </a:p>
+          <a:p>
+            <a:pPr>
+              <a:defRPr sz="1800">
+                <a:solidFill>
+                  <a:srgbClr val="242E42"/>
+                </a:solidFill>
+                <a:latin typeface="Calibri"/>
+              </a:defRPr>
+            </a:pPr>
+            <a:r>
+              <a:t>Pipeline logging captures runtime, step status, and row counts in pipeline_log.csv.</a:t>
+            </a:r>
+          </a:p>
+        </p:txBody>
+      </p:sp>
+    </p:spTree>
+  </p:cSld>
+  <p:clrMapOvr>
+    <a:masterClrMapping/>
+  </p:clrMapOvr>
+</p:sld>
+</file>
+
+<file path=ppt/slides/slide13.xml><?xml version="1.0" encoding="utf-8"?>
+<p:sld xmlns:a="http://schemas.openxmlformats.org/drawingml/2006/main" xmlns:p="http://schemas.openxmlformats.org/presentationml/2006/main" xmlns:r="http://schemas.openxmlformats.org/officeDocument/2006/relationships">
+  <p:cSld>
+    <p:bg>
+      <p:bgPr>
+        <a:solidFill>
+          <a:srgbClr val="FFFFFF"/>
+        </a:solidFill>
+        <a:effectLst/>
+      </p:bgPr>
+    </p:bg>
+    <p:spTree>
+      <p:nvGrpSpPr>
+        <p:cNvPr id="1" name=""/>
+        <p:cNvGrpSpPr/>
+        <p:nvPr/>
+      </p:nvGrpSpPr>
+      <p:grpSpPr/>
+      <p:sp>
+        <p:nvSpPr>
+          <p:cNvPr id="2" name="TextBox 1"/>
+          <p:cNvSpPr txBox="1"/>
+          <p:nvPr/>
+        </p:nvSpPr>
+        <p:spPr>
+          <a:xfrm>
+            <a:off x="640080" y="320040"/>
+            <a:ext cx="10972800" cy="822960"/>
+          </a:xfrm>
+          <a:prstGeom prst="rect">
+            <a:avLst/>
+          </a:prstGeom>
+          <a:noFill/>
+        </p:spPr>
+        <p:txBody>
+          <a:bodyPr wrap="none">
+            <a:spAutoFit/>
+          </a:bodyPr>
+          <a:lstStyle/>
+          <a:p>
+            <a:pPr>
+              <a:defRPr sz="3600" b="1">
+                <a:solidFill>
+                  <a:srgbClr val="0D1B3E"/>
+                </a:solidFill>
+                <a:latin typeface="Calibri"/>
+              </a:defRPr>
+            </a:pPr>
+            <a:r>
+              <a:t>Cloud architecture and role alignment</a:t>
+            </a:r>
+          </a:p>
+        </p:txBody>
+      </p:sp>
+      <p:sp>
+        <p:nvSpPr>
+          <p:cNvPr id="3" name="TextBox 2"/>
+          <p:cNvSpPr txBox="1"/>
+          <p:nvPr/>
+        </p:nvSpPr>
+        <p:spPr>
+          <a:xfrm>
+            <a:off x="822960" y="1645920"/>
+            <a:ext cx="10972800" cy="4389120"/>
+          </a:xfrm>
+          <a:prstGeom prst="rect">
+            <a:avLst/>
+          </a:prstGeom>
+          <a:noFill/>
+        </p:spPr>
+        <p:txBody>
+          <a:bodyPr wrap="none">
+            <a:spAutoFit/>
+          </a:bodyPr>
+          <a:lstStyle/>
+          <a:p>
+            <a:pPr>
+              <a:defRPr sz="1800">
+                <a:solidFill>
+                  <a:srgbClr val="242E42"/>
+                </a:solidFill>
+                <a:latin typeface="Calibri"/>
+              </a:defRPr>
+            </a:pPr>
+            <a:r>
+              <a:t>Azure-ready design: Blob Storage (raw), Databricks/ADF (orchestration), Azure SQL/Synapse (warehouse), Power BI (BI).</a:t>
+            </a:r>
+          </a:p>
+          <a:p>
+            <a:pPr>
+              <a:defRPr sz="1800">
+                <a:solidFill>
+                  <a:srgbClr val="242E42"/>
+                </a:solidFill>
+                <a:latin typeface="Calibri"/>
+              </a:defRPr>
+            </a:pPr>
+            <a:r>
+              <a:t>Config-driven settings via YAML support local-to-cloud environment transitions.</a:t>
+            </a:r>
+          </a:p>
+          <a:p>
+            <a:pPr>
+              <a:defRPr sz="1800">
+                <a:solidFill>
+                  <a:srgbClr val="242E42"/>
+                </a:solidFill>
+                <a:latin typeface="Calibri"/>
+              </a:defRPr>
+            </a:pPr>
+            <a:r>
+              <a:t>Stack aligns with Senior Data Analyst expectations: complex SQL, ETL/ELT, Python, PySpark, data modeling, quality/testing, BI communication.</a:t>
+            </a:r>
+          </a:p>
+        </p:txBody>
+      </p:sp>
+    </p:spTree>
+  </p:cSld>
+  <p:clrMapOvr>
+    <a:masterClrMapping/>
+  </p:clrMapOvr>
+</p:sld>
+</file>
+
+<file path=ppt/slides/slide14.xml><?xml version="1.0" encoding="utf-8"?>
+<p:sld xmlns:a="http://schemas.openxmlformats.org/drawingml/2006/main" xmlns:p="http://schemas.openxmlformats.org/presentationml/2006/main" xmlns:r="http://schemas.openxmlformats.org/officeDocument/2006/relationships">
+  <p:cSld>
+    <p:bg>
+      <p:bgPr>
+        <a:solidFill>
+          <a:srgbClr val="F5F8FC"/>
+        </a:solidFill>
+        <a:effectLst/>
+      </p:bgPr>
+    </p:bg>
+    <p:spTree>
+      <p:nvGrpSpPr>
+        <p:cNvPr id="1" name=""/>
+        <p:cNvGrpSpPr/>
+        <p:nvPr/>
+      </p:nvGrpSpPr>
+      <p:grpSpPr/>
+      <p:sp>
+        <p:nvSpPr>
+          <p:cNvPr id="2" name="TextBox 1"/>
+          <p:cNvSpPr txBox="1"/>
+          <p:nvPr/>
+        </p:nvSpPr>
+        <p:spPr>
+          <a:xfrm>
+            <a:off x="640080" y="320040"/>
+            <a:ext cx="10972800" cy="822960"/>
+          </a:xfrm>
+          <a:prstGeom prst="rect">
+            <a:avLst/>
+          </a:prstGeom>
+          <a:noFill/>
+        </p:spPr>
+        <p:txBody>
+          <a:bodyPr wrap="none">
+            <a:spAutoFit/>
+          </a:bodyPr>
+          <a:lstStyle/>
+          <a:p>
+            <a:pPr>
+              <a:defRPr sz="3600" b="1">
+                <a:solidFill>
+                  <a:srgbClr val="0D1B3E"/>
+                </a:solidFill>
+                <a:latin typeface="Calibri"/>
+              </a:defRPr>
+            </a:pPr>
+            <a:r>
+              <a:t>Pipeline automation</a:t>
+            </a:r>
+          </a:p>
+        </p:txBody>
+      </p:sp>
+      <p:sp>
+        <p:nvSpPr>
+          <p:cNvPr id="3" name="TextBox 2"/>
+          <p:cNvSpPr txBox="1"/>
+          <p:nvPr/>
+        </p:nvSpPr>
+        <p:spPr>
+          <a:xfrm>
+            <a:off x="822960" y="1645920"/>
+            <a:ext cx="10972800" cy="2560320"/>
+          </a:xfrm>
+          <a:prstGeom prst="rect">
+            <a:avLst/>
+          </a:prstGeom>
+          <a:noFill/>
+        </p:spPr>
+        <p:txBody>
+          <a:bodyPr wrap="none">
+            <a:spAutoFit/>
+          </a:bodyPr>
+          <a:lstStyle/>
+          <a:p>
+            <a:pPr>
+              <a:defRPr sz="1800">
+                <a:solidFill>
+                  <a:srgbClr val="242E42"/>
+                </a:solidFill>
+                <a:latin typeface="Calibri"/>
+              </a:defRPr>
+            </a:pPr>
+            <a:r>
+              <a:t>One command executes every stage end-to-end, from generation through BI export and presentation output.</a:t>
+            </a:r>
+          </a:p>
+          <a:p>
+            <a:pPr>
+              <a:defRPr sz="1800">
+                <a:solidFill>
+                  <a:srgbClr val="242E42"/>
+                </a:solidFill>
+                <a:latin typeface="Calibri"/>
+              </a:defRPr>
+            </a:pPr>
+            <a:r>
+              <a:t>Flow includes data quality checks, SQL modeling/analysis, optional PySpark processing, dashboarding, and Power BI-ready data.</a:t>
+            </a:r>
+          </a:p>
+          <a:p>
+            <a:pPr>
+              <a:defRPr sz="1800">
+                <a:solidFill>
+                  <a:srgbClr val="242E42"/>
+                </a:solidFill>
+                <a:latin typeface="Calibri"/>
+              </a:defRPr>
+            </a:pPr>
+            <a:r>
+              <a:t>Each step remains modular for interview walkthrough and future productionization.</a:t>
+            </a:r>
+          </a:p>
+        </p:txBody>
+      </p:sp>
+      <p:sp>
+        <p:nvSpPr>
+          <p:cNvPr id="4" name="Rounded Rectangle 3"/>
+          <p:cNvSpPr/>
+          <p:nvPr/>
+        </p:nvSpPr>
+        <p:spPr>
+          <a:xfrm>
+            <a:off x="1463040" y="3657600"/>
+            <a:ext cx="9418320" cy="2103120"/>
+          </a:xfrm>
+          <a:prstGeom prst="roundRect">
+            <a:avLst/>
+          </a:prstGeom>
+          <a:solidFill>
+            <a:srgbClr val="1A2334"/>
+          </a:solidFill>
+          <a:ln>
+            <a:solidFill>
+              <a:srgbClr val="0086AD"/>
+            </a:solidFill>
+          </a:ln>
+        </p:spPr>
+        <p:style>
+          <a:lnRef idx="1">
+            <a:schemeClr val="accent1"/>
+          </a:lnRef>
+          <a:fillRef idx="3">
+            <a:schemeClr val="accent1"/>
+          </a:fillRef>
+          <a:effectRef idx="2">
+            <a:schemeClr val="accent1"/>
+          </a:effectRef>
+          <a:fontRef idx="minor">
+            <a:schemeClr val="lt1"/>
+          </a:fontRef>
+        </p:style>
+        <p:txBody>
+          <a:bodyPr rtlCol="0" anchor="ctr"/>
+          <a:lstStyle/>
+          <a:p>
+            <a:pPr algn="ctr">
+              <a:defRPr sz="1200">
+                <a:solidFill>
+                  <a:srgbClr val="FFFFFF"/>
+                </a:solidFill>
+                <a:latin typeface="Consolas"/>
+              </a:defRPr>
+            </a:pPr>
+            <a:r>
+              <a:t>python3 scripts/run_pipeline.py</a:t>
+            </a:r>
+            <a:br/>
+            <a:br/>
+            <a:r>
+              <a:t># generate -&gt; clean -&gt; quality -&gt; load -&gt; SQL model/analysis</a:t>
+            </a:r>
+            <a:br/>
+            <a:r>
+              <a:t># -&gt; optional pyspark -&gt; dashboard -&gt; powerbi export -&gt; presentation</a:t>
+            </a:r>
+          </a:p>
+        </p:txBody>
+      </p:sp>
+    </p:spTree>
+  </p:cSld>
+  <p:clrMapOvr>
+    <a:masterClrMapping/>
+  </p:clrMapOvr>
+</p:sld>
+</file>
+
+<file path=ppt/slides/slide15.xml><?xml version="1.0" encoding="utf-8"?>
+<p:sld xmlns:a="http://schemas.openxmlformats.org/drawingml/2006/main" xmlns:p="http://schemas.openxmlformats.org/presentationml/2006/main" xmlns:r="http://schemas.openxmlformats.org/officeDocument/2006/relationships">
+  <p:cSld>
+    <p:bg>
+      <p:bgPr>
+        <a:solidFill>
+          <a:srgbClr val="FFFFFF"/>
+        </a:solidFill>
+        <a:effectLst/>
+      </p:bgPr>
+    </p:bg>
+    <p:spTree>
+      <p:nvGrpSpPr>
+        <p:cNvPr id="1" name=""/>
+        <p:cNvGrpSpPr/>
+        <p:nvPr/>
+      </p:nvGrpSpPr>
+      <p:grpSpPr/>
+      <p:sp>
+        <p:nvSpPr>
+          <p:cNvPr id="2" name="TextBox 1"/>
+          <p:cNvSpPr txBox="1"/>
+          <p:nvPr/>
+        </p:nvSpPr>
+        <p:spPr>
+          <a:xfrm>
+            <a:off x="640080" y="320040"/>
+            <a:ext cx="10972800" cy="822960"/>
+          </a:xfrm>
+          <a:prstGeom prst="rect">
+            <a:avLst/>
+          </a:prstGeom>
+          <a:noFill/>
+        </p:spPr>
+        <p:txBody>
+          <a:bodyPr wrap="none">
+            <a:spAutoFit/>
+          </a:bodyPr>
+          <a:lstStyle/>
+          <a:p>
+            <a:pPr>
+              <a:defRPr sz="3600" b="1">
+                <a:solidFill>
+                  <a:srgbClr val="0D1B3E"/>
+                </a:solidFill>
+                <a:latin typeface="Calibri"/>
+              </a:defRPr>
+            </a:pPr>
+            <a:r>
+              <a:t>Key insights from the data</a:t>
+            </a:r>
+          </a:p>
+        </p:txBody>
+      </p:sp>
+      <p:sp>
+        <p:nvSpPr>
+          <p:cNvPr id="3" name="TextBox 2"/>
+          <p:cNvSpPr txBox="1"/>
+          <p:nvPr/>
+        </p:nvSpPr>
+        <p:spPr>
+          <a:xfrm>
+            <a:off x="822960" y="1645920"/>
+            <a:ext cx="10972800" cy="4389120"/>
+          </a:xfrm>
+          <a:prstGeom prst="rect">
+            <a:avLst/>
+          </a:prstGeom>
+          <a:noFill/>
+        </p:spPr>
+        <p:txBody>
+          <a:bodyPr wrap="none">
+            <a:spAutoFit/>
+          </a:bodyPr>
+          <a:lstStyle/>
+          <a:p>
+            <a:pPr>
+              <a:defRPr sz="1800">
+                <a:solidFill>
+                  <a:srgbClr val="242E42"/>
+                </a:solidFill>
+                <a:latin typeface="Calibri"/>
+              </a:defRPr>
+            </a:pPr>
+            <a:r>
+              <a:t>Search_Google drives the largest spend and strongest CTR, making it a high-volume performance engine.</a:t>
+            </a:r>
+          </a:p>
+          <a:p>
+            <a:pPr>
+              <a:defRPr sz="1800">
+                <a:solidFill>
+                  <a:srgbClr val="242E42"/>
+                </a:solidFill>
+                <a:latin typeface="Calibri"/>
+              </a:defRPr>
+            </a:pPr>
+            <a:r>
+              <a:t>Email_Newsletter delivers the most efficient acquisition cost (lowest CPA), indicating high conversion efficiency.</a:t>
+            </a:r>
+          </a:p>
+          <a:p>
+            <a:pPr>
+              <a:defRPr sz="1800">
+                <a:solidFill>
+                  <a:srgbClr val="242E42"/>
+                </a:solidFill>
+                <a:latin typeface="Calibri"/>
+              </a:defRPr>
+            </a:pPr>
+            <a:r>
+              <a:t>Display_Programmatic has the weakest CTR and highest CPA, suggesting creative or targeting optimization is needed.</a:t>
+            </a:r>
+          </a:p>
+          <a:p>
+            <a:pPr>
+              <a:defRPr sz="1800">
+                <a:solidFill>
+                  <a:srgbClr val="242E42"/>
+                </a:solidFill>
+                <a:latin typeface="Calibri"/>
+              </a:defRPr>
+            </a:pPr>
+            <a:r>
+              <a:t>Cross-channel visibility helps rebalance budget toward both scale (Search) and efficiency (Email).</a:t>
+            </a:r>
+          </a:p>
+        </p:txBody>
+      </p:sp>
+    </p:spTree>
+  </p:cSld>
+  <p:clrMapOvr>
+    <a:masterClrMapping/>
+  </p:clrMapOvr>
+</p:sld>
+</file>
+
+<file path=ppt/slides/slide16.xml><?xml version="1.0" encoding="utf-8"?>
 <p:sld xmlns:a="http://schemas.openxmlformats.org/drawingml/2006/main" xmlns:p="http://schemas.openxmlformats.org/presentationml/2006/main" xmlns:r="http://schemas.openxmlformats.org/officeDocument/2006/relationships">
   <p:cSld>
     <p:bg>
@@ -3601,7 +4253,7 @@
               </a:defRPr>
             </a:pPr>
             <a:r>
-              <a:t>Reliable pipeline, clear metrics, actionable insights</a:t>
+              <a:t>Reliable pipeline, clear metrics, cloud-ready analytical design</a:t>
             </a:r>
           </a:p>
         </p:txBody>
@@ -3637,7 +4289,7 @@
               </a:defRPr>
             </a:pPr>
             <a:r>
-              <a:t>This project demonstrates a complete marketing analytics flow from ingestion to decision-ready dashboarding.</a:t>
+              <a:t>This project now demonstrates an interview-ready analytics stack from ETL through dimensional modeling and BI delivery.</a:t>
             </a:r>
           </a:p>
           <a:p>
@@ -3650,7 +4302,7 @@
               </a:defRPr>
             </a:pPr>
             <a:r>
-              <a:t>The same architecture can be scaled to real ad platform exports and scheduled production runs.</a:t>
+              <a:t>It combines pandas and PySpark processing, advanced SQL, data quality/testing controls, and Azure deployment awareness.</a:t>
             </a:r>
           </a:p>
           <a:p>
@@ -3663,7 +4315,7 @@
               </a:defRPr>
             </a:pPr>
             <a:r>
-              <a:t>Outcome: cleaner reporting, faster analysis, and better budget decisions across channels.</a:t>
+              <a:t>Outcome: repeatable analytics workflows with strong technical depth and clear business communication.</a:t>
             </a:r>
           </a:p>
         </p:txBody>
@@ -4146,7 +4798,7 @@
               </a:defRPr>
             </a:pPr>
             <a:r>
-              <a:t>SQL</a:t>
+              <a:t>SQL + Window Functions</a:t>
             </a:r>
           </a:p>
           <a:p>
@@ -4161,7 +4813,7 @@
               </a:defRPr>
             </a:pPr>
             <a:r>
-              <a:t>Answers business questions on cost, CTR trends, and CPA.</a:t>
+              <a:t>Drives CTE, LAG, RANK, rolling, and cumulative analysis.</a:t>
             </a:r>
           </a:p>
         </p:txBody>
@@ -4215,7 +4867,7 @@
               </a:defRPr>
             </a:pPr>
             <a:r>
-              <a:t>Plotly</a:t>
+              <a:t>PySpark</a:t>
             </a:r>
           </a:p>
           <a:p>
@@ -4230,7 +4882,76 @@
               </a:defRPr>
             </a:pPr>
             <a:r>
-              <a:t>Builds interactive KPI and trend dashboard visuals.</a:t>
+              <a:t>Shows scalable transformation and window-based feature engineering.</a:t>
+            </a:r>
+          </a:p>
+        </p:txBody>
+      </p:sp>
+      <p:sp>
+        <p:nvSpPr>
+          <p:cNvPr id="8" name="Rounded Rectangle 7"/>
+          <p:cNvSpPr/>
+          <p:nvPr/>
+        </p:nvSpPr>
+        <p:spPr>
+          <a:xfrm>
+            <a:off x="8595359" y="3840480"/>
+            <a:ext cx="3749039" cy="1828800"/>
+          </a:xfrm>
+          <a:prstGeom prst="roundRect">
+            <a:avLst/>
+          </a:prstGeom>
+          <a:solidFill>
+            <a:srgbClr val="F5F8FC"/>
+          </a:solidFill>
+          <a:ln>
+            <a:solidFill>
+              <a:srgbClr val="0086AD"/>
+            </a:solidFill>
+          </a:ln>
+        </p:spPr>
+        <p:style>
+          <a:lnRef idx="1">
+            <a:schemeClr val="accent1"/>
+          </a:lnRef>
+          <a:fillRef idx="3">
+            <a:schemeClr val="accent1"/>
+          </a:fillRef>
+          <a:effectRef idx="2">
+            <a:schemeClr val="accent1"/>
+          </a:effectRef>
+          <a:fontRef idx="minor">
+            <a:schemeClr val="lt1"/>
+          </a:fontRef>
+        </p:style>
+        <p:txBody>
+          <a:bodyPr rtlCol="0" anchor="ctr"/>
+          <a:lstStyle/>
+          <a:p>
+            <a:pPr algn="ctr">
+              <a:defRPr b="1" sz="2000">
+                <a:solidFill>
+                  <a:srgbClr val="0D1B3E"/>
+                </a:solidFill>
+              </a:defRPr>
+            </a:pPr>
+            <a:r>
+              <a:t>Plotly + Power BI Exports</a:t>
+            </a:r>
+          </a:p>
+          <a:p>
+            <a:pPr>
+              <a:spcBef>
+                <a:spcPts val="600"/>
+              </a:spcBef>
+              <a:defRPr sz="1300">
+                <a:solidFill>
+                  <a:srgbClr val="242E42"/>
+                </a:solidFill>
+              </a:defRPr>
+            </a:pPr>
+            <a:r>
+              <a:t>Interactive dashboard plus BI-ready semantic extracts.</a:t>
             </a:r>
           </a:p>
         </p:txBody>

</xml_diff>